<commit_message>
Sync PPTX build script with latest outline: Privacy Stack, updated notes
Co-Authored-By: Claude Opus 4.6 (1M context) <noreply@anthropic.com>
</commit_message>
<xml_diff>
--- a/slides.pptx
+++ b/slides.pptx
@@ -510,7 +510,7 @@
           <a:lstStyle/>
           <a:p>
             <a:r>
-              <a:t>Hi, I'm Tomer Weller, CPO at the Stellar Development Foundation. I've been in crypto for almost 9 years and for the last couple of years, privacy has been my main focus. This talk is about what we've learned in discussions with institutions about privacy.</a:t>
+              <a:t>Hi, I'm Tomer, CPO at the Stellar Development Foundation. I've been in crypto for almost 9 years and for the last couple of years, privacy has been one of my focal points. This talk is about what we've learned in discussions with institutions about privacy.</a:t>
             </a:r>
           </a:p>
         </p:txBody>
@@ -686,7 +686,7 @@
           <a:p/>
           <a:p>
             <a:r>
-              <a:t>For these institutions privacy means something different -- it means managing visibility in a way that allows them to stay competitive but also in compliance.</a:t>
+              <a:t>For these institutions privacy means something different -- it means managing visibility in a way that allows them to stay competitive and compliant.</a:t>
             </a:r>
           </a:p>
           <a:p/>
@@ -792,7 +792,7 @@
           <a:p/>
           <a:p>
             <a:r>
-              <a:t>Transition: This is what I call "Privacy Dead Ends".</a:t>
+              <a:t>Transition: Not recognizing the privacy spectrum has led us to develop what I call "Privacy Dead Ends".</a:t>
             </a:r>
           </a:p>
         </p:txBody>
@@ -862,13 +862,13 @@
           <a:lstStyle/>
           <a:p>
             <a:r>
-              <a:t>When we started looking at privacy for Stellar, we realized that most privacy solutions end up in one of two failure modes, or "dead ends".</a:t>
+              <a:t>When we started looking at privacy for Stellar, we realized that most privacy solutions today end up in one of two failure modes, or "dead ends".</a:t>
             </a:r>
           </a:p>
           <a:p/>
           <a:p>
             <a:r>
-              <a:t>All-or-Nothing: Privacy solutions that have two modes: full transparency or full privacy, nothing in between. This can take the shape of a smart contract pool, an L2 or an appchain - but the premise is the same. Unfortunately, this doesn't leave room for regulated financial institutions to engage with.</a:t>
+              <a:t>All-or-Nothing: Privacy solutions that have two modes: full transparency or full privacy, nothing in between. This can take the shape of a smart contract pool, an L2 or an appchain - but the premise is the same: all or nothing. Unfortunately, this doesn't leave room for nuance for regulated financial institutions to engage with.</a:t>
             </a:r>
           </a:p>
           <a:p/>
@@ -950,31 +950,25 @@
           <a:lstStyle/>
           <a:p>
             <a:r>
-              <a:t>The answer is simple: a clear architectural separation.</a:t>
+              <a:t>We think that the answer is simple: a clear architectural separation.</a:t>
             </a:r>
           </a:p>
           <a:p/>
           <a:p>
             <a:r>
-              <a:t>An open, transparent base layer -- a maximally auditable source of truth. This is the default - this is the primary issuance platform. Anyone can verify - interoperability is trivial.</a:t>
+              <a:t>Transparency first. The base layer stays open and auditable. This might come as a surprise given that this is a talk about privacy but transparency is a core value proposition of blockchains for institutions. The fact that an executive at an asset management company can go on a block explorer and see the total supply of an asset and its distribution - that is a feature - not a bug - they love that shit.</a:t>
             </a:r>
           </a:p>
           <a:p/>
           <a:p>
             <a:r>
-              <a:t>Privacy protocols built on top. Different privacy guarantees, different administrative controls, different underlying tech.</a:t>
+              <a:t>Building blocks for privacy. The base layer should provide the primitives that enable privacy -- without enshrining a specific type of privacy. We've seen L1s try to enshrine privacy - sometimes it ends poorly with bugs, sometimes it's just obsolete by the time it comes out. With Stellar we took a building blocks approach and our X-Ray upgrade earlier this year introduced an advanced set of ZK primitives that now enable many different privacy protocols.</a:t>
             </a:r>
           </a:p>
           <a:p/>
           <a:p>
             <a:r>
-              <a:t>Why transparency first? This might come as a surprise given that this is a talk about privacy but transparency is a core value proposition of blockchains. The fact that an executive at an asset manager company can go on a block explorer and see the total supply of an asset and its distribution - that is a feature - not a bug - they love that shit.</a:t>
-            </a:r>
-          </a:p>
-          <a:p/>
-          <a:p>
-            <a:r>
-              <a:t>With that said, our base layers should provide a rich set of building blocks for privacy. Stellar's X-Ray upgrade is an example of this approach -- adding ZK primitives (BN254, Poseidon) at the protocol level so that application developers can build configurable privacy without compromising the transparency of the base chain.</a:t>
+              <a:t>And that's the final layer: Privacy protocols on top. Different protocols for different privacy guarantees, different administrative controls, different underlying tech. Most importantly: there will be many of them.</a:t>
             </a:r>
           </a:p>
           <a:p/>
@@ -1050,25 +1044,25 @@
           <a:lstStyle/>
           <a:p>
             <a:r>
-              <a:t>We're going to focus on Private Payments. There's interesting stuff happening in private defi but these are still a ways out.</a:t>
+              <a:t>We're going to focus on Private Payments. There's interesting stuff happening in private defi and trading but these are still a ways out and payments are by far the most important and immediate use case.</a:t>
             </a:r>
           </a:p>
           <a:p/>
           <a:p>
             <a:r>
-              <a:t>The two main families of private payment protocols that we see are confidential tokens and privacy pools.</a:t>
+              <a:t>We're seeing two main families of private payment protocols these days, the first one is confidential tokens.</a:t>
             </a:r>
           </a:p>
           <a:p/>
           <a:p>
             <a:r>
-              <a:t>Confidential Tokens: Hide the what -- payment amounts and balances are concealed. But the sender and receiver are still visible on-chain. You know who's transacting, you just can't see how much. This is great for when counterparty relationships are known - for example with payroll, people know I'm employed by SDF but my salary is private. There are a bunch of different implementations of this. Stellar is part of the confidential token association and we're working with OpenZeppelin on an implementation. Narrower privacy guarantees but the tech is fairly scalable and it's a bit easier for compliance.</a:t>
+              <a:t>Confidential Tokens: Hide the what -- payment amounts and balances are concealed. But the sender and receiver are still visible on-chain. You know who's transacting, you just can't see how much. This is great for when counterparty relationships are known. For example with payroll, people know I'm employed by SDF but my salary is private. There are a bunch of different implementations of this. Stellar is part of the confidential token association and we're working with OpenZeppelin on an implementation. Confidential tokens deliver narrower privacy guarantees but the tech is fairly scalable and it's a bit easier for compliance.</a:t>
             </a:r>
           </a:p>
           <a:p/>
           <a:p>
             <a:r>
-              <a:t>Privacy Pools: Payment protocols that also hide the who -- funds are mixed so that sender and receivers identities are hidden. This provides anonymity, not just confidentiality. Much stronger privacy guarantees but they inherently mix funds, which means legitimate funds can be commingled with illicit funds - which there are ways to tackle.</a:t>
+              <a:t>The second family we're seeing are privacy pools. These are payment protocols that hide the what and the who -- funds are mixed so that sender and receiver identities are hidden. This provides anonymity, not just confidentiality. Some notable examples are 0xBow in the Ethereum ecosystem, and Nethermind is building a dedicated Stellar implementation -- SPP (Stellar Private Payments). Privacy Pools have much stronger privacy guarantees but they inherently mix funds, which means legitimate funds can be commingled with illicit funds - which there are ways to tackle.</a:t>
             </a:r>
           </a:p>
           <a:p/>
@@ -1144,43 +1138,43 @@
           <a:lstStyle/>
           <a:p>
             <a:r>
-              <a:t>At Stellar, we've been working with various builders in the space to define a compliance menu of opt-in administrative controls. The asterisk is deliberate. First of all I'm not a lawyer, and also regulators haven't defined what compliance looks like for on-chain privacy yet. These are the administrative controls we're starting to see as requirements, this is not a comprehensive list and the idea is to have these as configurable opt-in.</a:t>
+              <a:t>At Stellar, we've been working with various builders in the space to define a compliance menu of opt-in administrative controls. The asterisk is deliberate. First of all I'm not a lawyer, and also regulators haven't defined what compliance looks like for on-chain privacy yet. These are the administrative controls we're starting to see as requirements, this is not a comprehensive list and the idea is to have these as configurable opt-in as needed.</a:t>
             </a:r>
           </a:p>
           <a:p/>
           <a:p>
             <a:r>
-              <a:t>Selective Disclosure (View Keys): The user chooses to reveal specific transaction details to specific parties. This allows the user to show a source of funds on demand.</a:t>
+              <a:t>Selective Disclosure (View Keys): The user chooses to reveal specific transaction details to specific parties. This allows the user to show a source of funds on demand. This is a very powerful primitive that has existed for a while, but unfortunately we haven't seen great products built around it yet.</a:t>
             </a:r>
           </a:p>
           <a:p/>
           <a:p>
             <a:r>
-              <a:t>Non-Selective Disclosure (Auditor Keys): A third party authority holds a key that can view all transactions within a scope. This means that if a law enforcement agency has a subpoena they have an actual door to knock on.</a:t>
+              <a:t>Non-Selective Disclosure (Auditor Keys): A third party authority (e.g., an issuer or a pool operator) holds a key that can view all transactions within a scope. This means that if a law enforcement agency has a subpoena they have an actual door to knock on.</a:t>
             </a:r>
           </a:p>
           <a:p/>
           <a:p>
             <a:r>
-              <a:t>Association Sets: An allow list controlled by a pool operator - it ensures that all funds mixed come from approved addresses and reduces the risk of commingling with illicit funds.</a:t>
+              <a:t>Association Sets have been pioneered with Privacy Pools, these are allow lists controlled by a pool operator - they ensure that all funds mixed come from approved addresses and reduces the risk of commingling with illicit funds.</a:t>
             </a:r>
           </a:p>
           <a:p/>
           <a:p>
             <a:r>
-              <a:t>Forced Transparent Withdrawals: What happens if an account gets revoked? They're forced to withdraw transparently -- no hiding behind the pool on the way out. 0xBow calls this rage quit.</a:t>
+              <a:t>Forced Transparent Withdrawals: These address an issue with association sets: what happens if an account gets revoked? They're forced to withdraw transparently with no privacy guarantees. 0xBow calls this rage quit and we're starting to see more of these.</a:t>
             </a:r>
           </a:p>
           <a:p/>
           <a:p>
             <a:r>
-              <a:t>Clawback: If clawbacks are triggering for you then you are in the wrong room and you are not ready for what's coming next. Tokenization is at full speed and regulated assets often require clawback capabilities.</a:t>
+              <a:t>Clawback: And finally, yes - clawback. If clawbacks are triggering for you then you are in the wrong room and you are not ready for what's coming next. Tokenization is at full speed and regulated assets often require clawback capabilities. If we want to see RWA issuers have first class support for privacy on blockchains - they need clawback capabilities.</a:t>
             </a:r>
           </a:p>
           <a:p/>
           <a:p>
             <a:r>
-              <a:t>Transition: These are dials, not switches. Different combinations serve different jurisdictions, use cases, and risk profiles.</a:t>
+              <a:t>Transition: This menu is a starting point to let you compose the type of compliance you need. If you're in this room and this menu is offensive to you - let us know - it's work in progress and we'd love to get feedback.</a:t>
             </a:r>
           </a:p>
         </p:txBody>
@@ -1256,19 +1250,19 @@
           <a:p/>
           <a:p>
             <a:r>
-              <a:t>We've been building privacy with ideology first and that's great -- but it's not enough. Institutions need privacy too, and for them it's more nuanced.</a:t>
+              <a:t>In crypto, we've been building privacy with ideology first and that's great -- but it's not enough. Institutions need privacy too, and for them it's more nuanced.</a:t>
             </a:r>
           </a:p>
           <a:p/>
           <a:p>
             <a:r>
-              <a:t>Privacy is a spectrum. Different jurisdictions, different use cases, different tech. There's no single answer and that's okay -- that's actually the point.</a:t>
+              <a:t>Privacy is a spectrum. Different jurisdictions, different use cases, different tech. There's no single answer and that's okay.</a:t>
             </a:r>
           </a:p>
           <a:p/>
           <a:p>
             <a:r>
-              <a:t>The right approach is transparency first -- keep the base layer open, build configurable privacy on top. Confidential tokens, privacy pools, a compliance menu of administrative controls. Dials, not switches.</a:t>
+              <a:t>The right approach is transparency first -- keep the base layer open, provide the low-level building blocks and build configurable privacy on top: things like confidential tokens and privacy pools, administrative controls as needed.</a:t>
             </a:r>
           </a:p>
           <a:p/>
@@ -4849,7 +4843,7 @@
               </a:defRPr>
             </a:pPr>
             <a:r>
-              <a:t>Transparency First</a:t>
+              <a:t>The Privacy Stack</a:t>
             </a:r>
           </a:p>
         </p:txBody>
@@ -4882,7 +4876,7 @@
                 </a:solidFill>
                 <a:latin typeface="Inter"/>
               </a:rPr>
-              <a:t>Open, transparent base layer</a:t>
+              <a:t>Transparency first</a:t>
             </a:r>
             <a:r>
               <a:rPr sz="2200" b="0">
@@ -4891,7 +4885,7 @@
                 </a:solidFill>
                 <a:latin typeface="Inter"/>
               </a:rPr>
-              <a:t> -- maximally auditable source of truth</a:t>
+              <a:t> -- the base layer stays open and auditable</a:t>
             </a:r>
           </a:p>
         </p:txBody>
@@ -4924,7 +4918,7 @@
                 </a:solidFill>
                 <a:latin typeface="Inter"/>
               </a:rPr>
-              <a:t>Privacy protocols built on top</a:t>
+              <a:t>Building blocks for privacy</a:t>
             </a:r>
             <a:r>
               <a:rPr sz="2200" b="0">
@@ -4933,7 +4927,49 @@
                 </a:solidFill>
                 <a:latin typeface="Inter"/>
               </a:rPr>
-              <a:t> -- configurable, opt-in, different tech for different needs</a:t>
+              <a:t> -- primitives that enable privacy, without enshrining a specific type</a:t>
+            </a:r>
+          </a:p>
+        </p:txBody>
+      </p:sp>
+      <p:sp>
+        <p:nvSpPr>
+          <p:cNvPr id="5" name="TextBox 4"/>
+          <p:cNvSpPr txBox="1"/>
+          <p:nvPr/>
+        </p:nvSpPr>
+        <p:spPr>
+          <a:xfrm>
+            <a:off x="1097280" y="4389120"/>
+            <a:ext cx="9601200" cy="548640"/>
+          </a:xfrm>
+          <a:prstGeom prst="rect">
+            <a:avLst/>
+          </a:prstGeom>
+          <a:noFill/>
+        </p:spPr>
+        <p:txBody>
+          <a:bodyPr wrap="square"/>
+          <a:lstStyle/>
+          <a:p>
+            <a:pPr algn="l"/>
+            <a:r>
+              <a:rPr sz="2200" b="1">
+                <a:solidFill>
+                  <a:srgbClr val="FDDA24"/>
+                </a:solidFill>
+                <a:latin typeface="Inter"/>
+              </a:rPr>
+              <a:t>Privacy protocols on top</a:t>
+            </a:r>
+            <a:r>
+              <a:rPr sz="2200" b="0">
+                <a:solidFill>
+                  <a:srgbClr val="D6D2C4"/>
+                </a:solidFill>
+                <a:latin typeface="Inter"/>
+              </a:rPr>
+              <a:t> -- different guarantees, different controls, many of them</a:t>
             </a:r>
           </a:p>
         </p:txBody>
@@ -5017,6 +5053,39 @@
                       </p:childTnLst>
                     </p:cTn>
                   </p:par>
+                  <p:par>
+                    <p:cTn id="9" fill="hold">
+                      <p:stCondLst>
+                        <p:cond delay="0"/>
+                      </p:stCondLst>
+                      <p:childTnLst>
+                        <p:par>
+                          <p:cTn id="10" presetID="1" presetClass="entr" presetSubtype="0" fill="hold" nodeType="clickEffect">
+                            <p:stCondLst>
+                              <p:cond delay="0"/>
+                            </p:stCondLst>
+                            <p:childTnLst>
+                              <p:set>
+                                <p:cBhvr>
+                                  <p:cTn id="11" dur="1" fill="hold">
+                                    <p:stCondLst>
+                                      <p:cond delay="0"/>
+                                    </p:stCondLst>
+                                  </p:cTn>
+                                  <p:tgtEl>
+                                    <p:spTgt spid="5"/>
+                                  </p:tgtEl>
+                                </p:cBhvr>
+                                <p:to>
+                                  <p:strVal val="visible"/>
+                                </p:to>
+                              </p:set>
+                            </p:childTnLst>
+                          </p:cTn>
+                        </p:par>
+                      </p:childTnLst>
+                    </p:cTn>
+                  </p:par>
                 </p:childTnLst>
               </p:cTn>
               <p:prevCondLst>
@@ -5173,7 +5242,7 @@
                 </a:solidFill>
                 <a:latin typeface="Inter"/>
               </a:rPr>
-              <a:t> -- hide the who (sender, receiver)</a:t>
+              <a:t> -- hide the what and the who (sender, receiver)</a:t>
             </a:r>
           </a:p>
         </p:txBody>

</xml_diff>

<commit_message>
Fix PPTX animations: add bldLst so bullets start hidden and appear on click
Co-Authored-By: Claude Opus 4.6 (1M context) <noreply@anthropic.com>
</commit_message>
<xml_diff>
--- a/slides.pptx
+++ b/slides.pptx
@@ -4792,6 +4792,10 @@
         </p:cTn>
       </p:par>
     </p:tnLst>
+    <p:bldLst>
+      <p:bldP spid="3" grpId="0" animBg="1"/>
+      <p:bldP spid="4" grpId="0" animBg="1"/>
+    </p:bldLst>
   </p:timing>
 </p:sld>
 </file>
@@ -5107,6 +5111,11 @@
         </p:cTn>
       </p:par>
     </p:tnLst>
+    <p:bldLst>
+      <p:bldP spid="3" grpId="0" animBg="1"/>
+      <p:bldP spid="4" grpId="0" animBg="1"/>
+      <p:bldP spid="5" grpId="0" animBg="1"/>
+    </p:bldLst>
   </p:timing>
 </p:sld>
 </file>
@@ -5347,6 +5356,10 @@
         </p:cTn>
       </p:par>
     </p:tnLst>
+    <p:bldLst>
+      <p:bldP spid="3" grpId="0" animBg="1"/>
+      <p:bldP spid="4" grpId="0" animBg="1"/>
+    </p:bldLst>
   </p:timing>
 </p:sld>
 </file>
@@ -5767,6 +5780,13 @@
         </p:cTn>
       </p:par>
     </p:tnLst>
+    <p:bldLst>
+      <p:bldP spid="3" grpId="0" animBg="1"/>
+      <p:bldP spid="4" grpId="0" animBg="1"/>
+      <p:bldP spid="5" grpId="0" animBg="1"/>
+      <p:bldP spid="6" grpId="0" animBg="1"/>
+      <p:bldP spid="7" grpId="0" animBg="1"/>
+    </p:bldLst>
   </p:timing>
 </p:sld>
 </file>

</xml_diff>

<commit_message>
Add bullet points to Privacy is a Spectrum slide
Co-Authored-By: Claude Opus 4.6 (1M context) <noreply@anthropic.com>
</commit_message>
<xml_diff>
--- a/slides.pptx
+++ b/slides.pptx
@@ -4522,8 +4522,8 @@
         </p:nvSpPr>
         <p:spPr>
           <a:xfrm>
-            <a:off x="1097280" y="2560320"/>
-            <a:ext cx="9601200" cy="1828800"/>
+            <a:off x="1097280" y="1371600"/>
+            <a:ext cx="9601200" cy="1371600"/>
           </a:xfrm>
           <a:prstGeom prst="rect">
             <a:avLst/>
@@ -4548,11 +4548,271 @@
           </a:p>
         </p:txBody>
       </p:sp>
+      <p:sp>
+        <p:nvSpPr>
+          <p:cNvPr id="3" name="TextBox 2"/>
+          <p:cNvSpPr txBox="1"/>
+          <p:nvPr/>
+        </p:nvSpPr>
+        <p:spPr>
+          <a:xfrm>
+            <a:off x="1097280" y="3108960"/>
+            <a:ext cx="9601200" cy="548640"/>
+          </a:xfrm>
+          <a:prstGeom prst="rect">
+            <a:avLst/>
+          </a:prstGeom>
+          <a:noFill/>
+        </p:spPr>
+        <p:txBody>
+          <a:bodyPr wrap="square"/>
+          <a:lstStyle/>
+          <a:p>
+            <a:pPr algn="l"/>
+            <a:r>
+              <a:rPr sz="2200" b="1">
+                <a:solidFill>
+                  <a:srgbClr val="FDDA24"/>
+                </a:solidFill>
+                <a:latin typeface="Inter"/>
+              </a:rPr>
+              <a:t>Jurisdictions vary</a:t>
+            </a:r>
+            <a:r>
+              <a:rPr sz="2200" b="0">
+                <a:solidFill>
+                  <a:srgbClr val="D6D2C4"/>
+                </a:solidFill>
+                <a:latin typeface="Inter"/>
+              </a:rPr>
+              <a:t> -- US ≠ EU ≠ Singapore ≠ Brazil</a:t>
+            </a:r>
+          </a:p>
+        </p:txBody>
+      </p:sp>
+      <p:sp>
+        <p:nvSpPr>
+          <p:cNvPr id="4" name="TextBox 3"/>
+          <p:cNvSpPr txBox="1"/>
+          <p:nvPr/>
+        </p:nvSpPr>
+        <p:spPr>
+          <a:xfrm>
+            <a:off x="1097280" y="3749040"/>
+            <a:ext cx="9601200" cy="548640"/>
+          </a:xfrm>
+          <a:prstGeom prst="rect">
+            <a:avLst/>
+          </a:prstGeom>
+          <a:noFill/>
+        </p:spPr>
+        <p:txBody>
+          <a:bodyPr wrap="square"/>
+          <a:lstStyle/>
+          <a:p>
+            <a:pPr algn="l"/>
+            <a:r>
+              <a:rPr sz="2200" b="1">
+                <a:solidFill>
+                  <a:srgbClr val="FDDA24"/>
+                </a:solidFill>
+                <a:latin typeface="Inter"/>
+              </a:rPr>
+              <a:t>Use cases vary</a:t>
+            </a:r>
+            <a:r>
+              <a:rPr sz="2200" b="0">
+                <a:solidFill>
+                  <a:srgbClr val="D6D2C4"/>
+                </a:solidFill>
+                <a:latin typeface="Inter"/>
+              </a:rPr>
+              <a:t> -- payroll ≠ trading ≠ lending ≠ remittances</a:t>
+            </a:r>
+          </a:p>
+        </p:txBody>
+      </p:sp>
+      <p:sp>
+        <p:nvSpPr>
+          <p:cNvPr id="5" name="TextBox 4"/>
+          <p:cNvSpPr txBox="1"/>
+          <p:nvPr/>
+        </p:nvSpPr>
+        <p:spPr>
+          <a:xfrm>
+            <a:off x="1097280" y="4389120"/>
+            <a:ext cx="9601200" cy="548640"/>
+          </a:xfrm>
+          <a:prstGeom prst="rect">
+            <a:avLst/>
+          </a:prstGeom>
+          <a:noFill/>
+        </p:spPr>
+        <p:txBody>
+          <a:bodyPr wrap="square"/>
+          <a:lstStyle/>
+          <a:p>
+            <a:pPr algn="l"/>
+            <a:r>
+              <a:rPr sz="2200" b="1">
+                <a:solidFill>
+                  <a:srgbClr val="FDDA24"/>
+                </a:solidFill>
+                <a:latin typeface="Inter"/>
+              </a:rPr>
+              <a:t>Technology varies</a:t>
+            </a:r>
+            <a:r>
+              <a:rPr sz="2200" b="0">
+                <a:solidFill>
+                  <a:srgbClr val="D6D2C4"/>
+                </a:solidFill>
+                <a:latin typeface="Inter"/>
+              </a:rPr>
+              <a:t> -- ZK, FHE, MPC, TEEs</a:t>
+            </a:r>
+          </a:p>
+        </p:txBody>
+      </p:sp>
     </p:spTree>
   </p:cSld>
   <p:clrMapOvr>
     <a:masterClrMapping/>
   </p:clrMapOvr>
+  <p:timing>
+    <p:tnLst>
+      <p:par>
+        <p:cTn id="1" dur="indefinite" restart="never" nodeType="tmRoot">
+          <p:childTnLst>
+            <p:seq concurrent="1" nextAc="seek">
+              <p:cTn id="2" dur="indefinite" nodeType="mainSeq">
+                <p:childTnLst>
+                  <p:par>
+                    <p:cTn id="3" fill="hold">
+                      <p:stCondLst>
+                        <p:cond delay="0"/>
+                      </p:stCondLst>
+                      <p:childTnLst>
+                        <p:par>
+                          <p:cTn id="4" presetID="1" presetClass="entr" presetSubtype="0" fill="hold" nodeType="clickEffect">
+                            <p:stCondLst>
+                              <p:cond delay="0"/>
+                            </p:stCondLst>
+                            <p:childTnLst>
+                              <p:set>
+                                <p:cBhvr>
+                                  <p:cTn id="5" dur="1" fill="hold">
+                                    <p:stCondLst>
+                                      <p:cond delay="0"/>
+                                    </p:stCondLst>
+                                  </p:cTn>
+                                  <p:tgtEl>
+                                    <p:spTgt spid="3"/>
+                                  </p:tgtEl>
+                                </p:cBhvr>
+                                <p:to>
+                                  <p:strVal val="visible"/>
+                                </p:to>
+                              </p:set>
+                            </p:childTnLst>
+                          </p:cTn>
+                        </p:par>
+                      </p:childTnLst>
+                    </p:cTn>
+                  </p:par>
+                  <p:par>
+                    <p:cTn id="6" fill="hold">
+                      <p:stCondLst>
+                        <p:cond delay="0"/>
+                      </p:stCondLst>
+                      <p:childTnLst>
+                        <p:par>
+                          <p:cTn id="7" presetID="1" presetClass="entr" presetSubtype="0" fill="hold" nodeType="clickEffect">
+                            <p:stCondLst>
+                              <p:cond delay="0"/>
+                            </p:stCondLst>
+                            <p:childTnLst>
+                              <p:set>
+                                <p:cBhvr>
+                                  <p:cTn id="8" dur="1" fill="hold">
+                                    <p:stCondLst>
+                                      <p:cond delay="0"/>
+                                    </p:stCondLst>
+                                  </p:cTn>
+                                  <p:tgtEl>
+                                    <p:spTgt spid="4"/>
+                                  </p:tgtEl>
+                                </p:cBhvr>
+                                <p:to>
+                                  <p:strVal val="visible"/>
+                                </p:to>
+                              </p:set>
+                            </p:childTnLst>
+                          </p:cTn>
+                        </p:par>
+                      </p:childTnLst>
+                    </p:cTn>
+                  </p:par>
+                  <p:par>
+                    <p:cTn id="9" fill="hold">
+                      <p:stCondLst>
+                        <p:cond delay="0"/>
+                      </p:stCondLst>
+                      <p:childTnLst>
+                        <p:par>
+                          <p:cTn id="10" presetID="1" presetClass="entr" presetSubtype="0" fill="hold" nodeType="clickEffect">
+                            <p:stCondLst>
+                              <p:cond delay="0"/>
+                            </p:stCondLst>
+                            <p:childTnLst>
+                              <p:set>
+                                <p:cBhvr>
+                                  <p:cTn id="11" dur="1" fill="hold">
+                                    <p:stCondLst>
+                                      <p:cond delay="0"/>
+                                    </p:stCondLst>
+                                  </p:cTn>
+                                  <p:tgtEl>
+                                    <p:spTgt spid="5"/>
+                                  </p:tgtEl>
+                                </p:cBhvr>
+                                <p:to>
+                                  <p:strVal val="visible"/>
+                                </p:to>
+                              </p:set>
+                            </p:childTnLst>
+                          </p:cTn>
+                        </p:par>
+                      </p:childTnLst>
+                    </p:cTn>
+                  </p:par>
+                </p:childTnLst>
+              </p:cTn>
+              <p:prevCondLst>
+                <p:cond evt="onPrev" delay="0">
+                  <p:tgtEl>
+                    <p:sldTgt/>
+                  </p:tgtEl>
+                </p:cond>
+              </p:prevCondLst>
+              <p:nextCondLst>
+                <p:cond evt="onNext" delay="0">
+                  <p:tgtEl>
+                    <p:sldTgt/>
+                  </p:tgtEl>
+                </p:cond>
+              </p:nextCondLst>
+            </p:seq>
+          </p:childTnLst>
+        </p:cTn>
+      </p:par>
+    </p:tnLst>
+    <p:bldLst>
+      <p:bldP spid="3" grpId="0" animBg="1"/>
+      <p:bldP spid="4" grpId="0" animBg="1"/>
+      <p:bldP spid="5" grpId="0" animBg="1"/>
+    </p:bldLst>
+  </p:timing>
 </p:sld>
 </file>
 

</xml_diff>

<commit_message>
Add bullet points to closing slide in reveal.js and PPTX
Co-Authored-By: Claude Opus 4.6 (1M context) <noreply@anthropic.com>
</commit_message>
<xml_diff>
--- a/slides.pptx
+++ b/slides.pptx
@@ -6077,8 +6077,8 @@
         </p:nvSpPr>
         <p:spPr>
           <a:xfrm>
-            <a:off x="1097280" y="2560320"/>
-            <a:ext cx="9601200" cy="2286000"/>
+            <a:off x="1097280" y="1371600"/>
+            <a:ext cx="9601200" cy="1371600"/>
           </a:xfrm>
           <a:prstGeom prst="rect">
             <a:avLst/>
@@ -6090,7 +6090,7 @@
           <a:lstStyle/>
           <a:p>
             <a:pPr algn="l">
-              <a:defRPr sz="5400" b="1">
+              <a:defRPr sz="4400" b="1">
                 <a:solidFill>
                   <a:srgbClr val="F6F7F8"/>
                 </a:solidFill>
@@ -6107,11 +6107,347 @@
           </a:p>
         </p:txBody>
       </p:sp>
+      <p:sp>
+        <p:nvSpPr>
+          <p:cNvPr id="3" name="TextBox 2"/>
+          <p:cNvSpPr txBox="1"/>
+          <p:nvPr/>
+        </p:nvSpPr>
+        <p:spPr>
+          <a:xfrm>
+            <a:off x="1097280" y="3108960"/>
+            <a:ext cx="9601200" cy="548640"/>
+          </a:xfrm>
+          <a:prstGeom prst="rect">
+            <a:avLst/>
+          </a:prstGeom>
+          <a:noFill/>
+        </p:spPr>
+        <p:txBody>
+          <a:bodyPr wrap="square"/>
+          <a:lstStyle/>
+          <a:p>
+            <a:pPr algn="l"/>
+            <a:r>
+              <a:rPr sz="2200" b="1">
+                <a:solidFill>
+                  <a:srgbClr val="FDDA24"/>
+                </a:solidFill>
+                <a:latin typeface="Inter"/>
+              </a:rPr>
+              <a:t>Ideology first isn't enough</a:t>
+            </a:r>
+            <a:r>
+              <a:rPr sz="2200" b="0">
+                <a:solidFill>
+                  <a:srgbClr val="D6D2C4"/>
+                </a:solidFill>
+                <a:latin typeface="Inter"/>
+              </a:rPr>
+              <a:t> -- institutions need nuanced privacy</a:t>
+            </a:r>
+          </a:p>
+        </p:txBody>
+      </p:sp>
+      <p:sp>
+        <p:nvSpPr>
+          <p:cNvPr id="4" name="TextBox 3"/>
+          <p:cNvSpPr txBox="1"/>
+          <p:nvPr/>
+        </p:nvSpPr>
+        <p:spPr>
+          <a:xfrm>
+            <a:off x="1097280" y="3749040"/>
+            <a:ext cx="9601200" cy="548640"/>
+          </a:xfrm>
+          <a:prstGeom prst="rect">
+            <a:avLst/>
+          </a:prstGeom>
+          <a:noFill/>
+        </p:spPr>
+        <p:txBody>
+          <a:bodyPr wrap="square"/>
+          <a:lstStyle/>
+          <a:p>
+            <a:pPr algn="l"/>
+            <a:r>
+              <a:rPr sz="2200" b="1">
+                <a:solidFill>
+                  <a:srgbClr val="FDDA24"/>
+                </a:solidFill>
+                <a:latin typeface="Inter"/>
+              </a:rPr>
+              <a:t>Privacy is a spectrum</a:t>
+            </a:r>
+            <a:r>
+              <a:rPr sz="2200" b="0">
+                <a:solidFill>
+                  <a:srgbClr val="D6D2C4"/>
+                </a:solidFill>
+                <a:latin typeface="Inter"/>
+              </a:rPr>
+              <a:t> -- jurisdictions, use cases, tech all vary</a:t>
+            </a:r>
+          </a:p>
+        </p:txBody>
+      </p:sp>
+      <p:sp>
+        <p:nvSpPr>
+          <p:cNvPr id="5" name="TextBox 4"/>
+          <p:cNvSpPr txBox="1"/>
+          <p:nvPr/>
+        </p:nvSpPr>
+        <p:spPr>
+          <a:xfrm>
+            <a:off x="1097280" y="4389120"/>
+            <a:ext cx="9601200" cy="548640"/>
+          </a:xfrm>
+          <a:prstGeom prst="rect">
+            <a:avLst/>
+          </a:prstGeom>
+          <a:noFill/>
+        </p:spPr>
+        <p:txBody>
+          <a:bodyPr wrap="square"/>
+          <a:lstStyle/>
+          <a:p>
+            <a:pPr algn="l"/>
+            <a:r>
+              <a:rPr sz="2200" b="1">
+                <a:solidFill>
+                  <a:srgbClr val="FDDA24"/>
+                </a:solidFill>
+                <a:latin typeface="Inter"/>
+              </a:rPr>
+              <a:t>Transparency first</a:t>
+            </a:r>
+            <a:r>
+              <a:rPr sz="2200" b="0">
+                <a:solidFill>
+                  <a:srgbClr val="D6D2C4"/>
+                </a:solidFill>
+                <a:latin typeface="Inter"/>
+              </a:rPr>
+              <a:t> -- open base layer, building blocks, privacy on top</a:t>
+            </a:r>
+          </a:p>
+        </p:txBody>
+      </p:sp>
+      <p:sp>
+        <p:nvSpPr>
+          <p:cNvPr id="6" name="TextBox 5"/>
+          <p:cNvSpPr txBox="1"/>
+          <p:nvPr/>
+        </p:nvSpPr>
+        <p:spPr>
+          <a:xfrm>
+            <a:off x="1097280" y="5029200"/>
+            <a:ext cx="9601200" cy="548640"/>
+          </a:xfrm>
+          <a:prstGeom prst="rect">
+            <a:avLst/>
+          </a:prstGeom>
+          <a:noFill/>
+        </p:spPr>
+        <p:txBody>
+          <a:bodyPr wrap="square"/>
+          <a:lstStyle/>
+          <a:p>
+            <a:pPr algn="l"/>
+            <a:r>
+              <a:rPr sz="2200" b="1">
+                <a:solidFill>
+                  <a:srgbClr val="FDDA24"/>
+                </a:solidFill>
+                <a:latin typeface="Inter"/>
+              </a:rPr>
+              <a:t>The time is now</a:t>
+            </a:r>
+            <a:r>
+              <a:rPr sz="2200" b="0">
+                <a:solidFill>
+                  <a:srgbClr val="D6D2C4"/>
+                </a:solidFill>
+                <a:latin typeface="Inter"/>
+              </a:rPr>
+              <a:t> -- non-hostile regulation, institutions at the table, tech is ready</a:t>
+            </a:r>
+          </a:p>
+        </p:txBody>
+      </p:sp>
     </p:spTree>
   </p:cSld>
   <p:clrMapOvr>
     <a:masterClrMapping/>
   </p:clrMapOvr>
+  <p:timing>
+    <p:tnLst>
+      <p:par>
+        <p:cTn id="1" dur="indefinite" restart="never" nodeType="tmRoot">
+          <p:childTnLst>
+            <p:seq concurrent="1" nextAc="seek">
+              <p:cTn id="2" dur="indefinite" nodeType="mainSeq">
+                <p:childTnLst>
+                  <p:par>
+                    <p:cTn id="3" fill="hold">
+                      <p:stCondLst>
+                        <p:cond delay="0"/>
+                      </p:stCondLst>
+                      <p:childTnLst>
+                        <p:par>
+                          <p:cTn id="4" presetID="1" presetClass="entr" presetSubtype="0" fill="hold" nodeType="clickEffect">
+                            <p:stCondLst>
+                              <p:cond delay="0"/>
+                            </p:stCondLst>
+                            <p:childTnLst>
+                              <p:set>
+                                <p:cBhvr>
+                                  <p:cTn id="5" dur="1" fill="hold">
+                                    <p:stCondLst>
+                                      <p:cond delay="0"/>
+                                    </p:stCondLst>
+                                  </p:cTn>
+                                  <p:tgtEl>
+                                    <p:spTgt spid="3"/>
+                                  </p:tgtEl>
+                                </p:cBhvr>
+                                <p:to>
+                                  <p:strVal val="visible"/>
+                                </p:to>
+                              </p:set>
+                            </p:childTnLst>
+                          </p:cTn>
+                        </p:par>
+                      </p:childTnLst>
+                    </p:cTn>
+                  </p:par>
+                  <p:par>
+                    <p:cTn id="6" fill="hold">
+                      <p:stCondLst>
+                        <p:cond delay="0"/>
+                      </p:stCondLst>
+                      <p:childTnLst>
+                        <p:par>
+                          <p:cTn id="7" presetID="1" presetClass="entr" presetSubtype="0" fill="hold" nodeType="clickEffect">
+                            <p:stCondLst>
+                              <p:cond delay="0"/>
+                            </p:stCondLst>
+                            <p:childTnLst>
+                              <p:set>
+                                <p:cBhvr>
+                                  <p:cTn id="8" dur="1" fill="hold">
+                                    <p:stCondLst>
+                                      <p:cond delay="0"/>
+                                    </p:stCondLst>
+                                  </p:cTn>
+                                  <p:tgtEl>
+                                    <p:spTgt spid="4"/>
+                                  </p:tgtEl>
+                                </p:cBhvr>
+                                <p:to>
+                                  <p:strVal val="visible"/>
+                                </p:to>
+                              </p:set>
+                            </p:childTnLst>
+                          </p:cTn>
+                        </p:par>
+                      </p:childTnLst>
+                    </p:cTn>
+                  </p:par>
+                  <p:par>
+                    <p:cTn id="9" fill="hold">
+                      <p:stCondLst>
+                        <p:cond delay="0"/>
+                      </p:stCondLst>
+                      <p:childTnLst>
+                        <p:par>
+                          <p:cTn id="10" presetID="1" presetClass="entr" presetSubtype="0" fill="hold" nodeType="clickEffect">
+                            <p:stCondLst>
+                              <p:cond delay="0"/>
+                            </p:stCondLst>
+                            <p:childTnLst>
+                              <p:set>
+                                <p:cBhvr>
+                                  <p:cTn id="11" dur="1" fill="hold">
+                                    <p:stCondLst>
+                                      <p:cond delay="0"/>
+                                    </p:stCondLst>
+                                  </p:cTn>
+                                  <p:tgtEl>
+                                    <p:spTgt spid="5"/>
+                                  </p:tgtEl>
+                                </p:cBhvr>
+                                <p:to>
+                                  <p:strVal val="visible"/>
+                                </p:to>
+                              </p:set>
+                            </p:childTnLst>
+                          </p:cTn>
+                        </p:par>
+                      </p:childTnLst>
+                    </p:cTn>
+                  </p:par>
+                  <p:par>
+                    <p:cTn id="12" fill="hold">
+                      <p:stCondLst>
+                        <p:cond delay="0"/>
+                      </p:stCondLst>
+                      <p:childTnLst>
+                        <p:par>
+                          <p:cTn id="13" presetID="1" presetClass="entr" presetSubtype="0" fill="hold" nodeType="clickEffect">
+                            <p:stCondLst>
+                              <p:cond delay="0"/>
+                            </p:stCondLst>
+                            <p:childTnLst>
+                              <p:set>
+                                <p:cBhvr>
+                                  <p:cTn id="14" dur="1" fill="hold">
+                                    <p:stCondLst>
+                                      <p:cond delay="0"/>
+                                    </p:stCondLst>
+                                  </p:cTn>
+                                  <p:tgtEl>
+                                    <p:spTgt spid="6"/>
+                                  </p:tgtEl>
+                                </p:cBhvr>
+                                <p:to>
+                                  <p:strVal val="visible"/>
+                                </p:to>
+                              </p:set>
+                            </p:childTnLst>
+                          </p:cTn>
+                        </p:par>
+                      </p:childTnLst>
+                    </p:cTn>
+                  </p:par>
+                </p:childTnLst>
+              </p:cTn>
+              <p:prevCondLst>
+                <p:cond evt="onPrev" delay="0">
+                  <p:tgtEl>
+                    <p:sldTgt/>
+                  </p:tgtEl>
+                </p:cond>
+              </p:prevCondLst>
+              <p:nextCondLst>
+                <p:cond evt="onNext" delay="0">
+                  <p:tgtEl>
+                    <p:sldTgt/>
+                  </p:tgtEl>
+                </p:cond>
+              </p:nextCondLst>
+            </p:seq>
+          </p:childTnLst>
+        </p:cTn>
+      </p:par>
+    </p:tnLst>
+    <p:bldLst>
+      <p:bldP spid="3" grpId="0" animBg="1"/>
+      <p:bldP spid="4" grpId="0" animBg="1"/>
+      <p:bldP spid="5" grpId="0" animBg="1"/>
+      <p:bldP spid="6" grpId="0" animBg="1"/>
+    </p:bldLst>
+  </p:timing>
 </p:sld>
 </file>
 

</xml_diff>